<commit_message>
ini ETS bukan EAS
</commit_message>
<xml_diff>
--- a/uts.pptx
+++ b/uts.pptx
@@ -407,7 +407,7 @@
             <a:pPr>
               <a:defRPr/>
             </a:pPr>
-            <a:fld id="{C53E5644-23DA-4A08-4771-117A1BA54998}" type="slidenum">
+            <a:fld id="{73D8C093-A059-B9F5-F7AA-5C5853367082}" type="slidenum">
               <a:rPr/>
               <a:t/>
             </a:fld>
@@ -492,7 +492,7 @@
             <a:pPr>
               <a:defRPr/>
             </a:pPr>
-            <a:fld id="{D939881D-89E8-AD17-F297-187F9DD6D9AC}" type="slidenum">
+            <a:fld id="{B4333189-FE84-B9A7-1D1A-0C8FB1B2C4AB}" type="slidenum">
               <a:rPr/>
               <a:t/>
             </a:fld>
@@ -697,7 +697,7 @@
       </p:grpSpPr>
       <p:sp>
         <p:nvSpPr>
-          <p:cNvPr id="599139956" name="PlaceHolder 1"/>
+          <p:cNvPr id="1486611403" name="PlaceHolder 1"/>
           <p:cNvSpPr>
             <a:spLocks noGrp="1"/>
           </p:cNvSpPr>
@@ -722,7 +722,7 @@
       </p:sp>
       <p:sp>
         <p:nvSpPr>
-          <p:cNvPr id="1391360795" name="PlaceHolder 2"/>
+          <p:cNvPr id="1111443483" name="PlaceHolder 2"/>
           <p:cNvSpPr>
             <a:spLocks noGrp="1"/>
           </p:cNvSpPr>
@@ -747,7 +747,7 @@
       </p:sp>
       <p:sp>
         <p:nvSpPr>
-          <p:cNvPr id="511138845" name="PlaceHolder 3"/>
+          <p:cNvPr id="830754463" name="PlaceHolder 3"/>
           <p:cNvSpPr>
             <a:spLocks noGrp="1"/>
           </p:cNvSpPr>
@@ -793,7 +793,7 @@
       </p:grpSpPr>
       <p:sp>
         <p:nvSpPr>
-          <p:cNvPr id="1866176617" name="PlaceHolder 1"/>
+          <p:cNvPr id="214873441" name="PlaceHolder 1"/>
           <p:cNvSpPr>
             <a:spLocks noGrp="1"/>
           </p:cNvSpPr>
@@ -834,7 +834,7 @@
       </p:sp>
       <p:sp>
         <p:nvSpPr>
-          <p:cNvPr id="259412564" name="PlaceHolder 2"/>
+          <p:cNvPr id="1765546349" name="PlaceHolder 2"/>
           <p:cNvSpPr>
             <a:spLocks noGrp="1"/>
           </p:cNvSpPr>
@@ -878,7 +878,7 @@
       </p:sp>
       <p:sp>
         <p:nvSpPr>
-          <p:cNvPr id="1575769491" name="PlaceHolder 3"/>
+          <p:cNvPr id="958721437" name="PlaceHolder 3"/>
           <p:cNvSpPr>
             <a:spLocks noGrp="1"/>
           </p:cNvSpPr>
@@ -922,7 +922,7 @@
       </p:sp>
       <p:sp>
         <p:nvSpPr>
-          <p:cNvPr id="85165525" name="PlaceHolder 4"/>
+          <p:cNvPr id="193938760" name="PlaceHolder 4"/>
           <p:cNvSpPr>
             <a:spLocks noGrp="1"/>
           </p:cNvSpPr>
@@ -947,7 +947,7 @@
       </p:sp>
       <p:sp>
         <p:nvSpPr>
-          <p:cNvPr id="610186788" name="PlaceHolder 5"/>
+          <p:cNvPr id="1859074692" name="PlaceHolder 5"/>
           <p:cNvSpPr>
             <a:spLocks noGrp="1"/>
           </p:cNvSpPr>
@@ -972,7 +972,7 @@
       </p:sp>
       <p:sp>
         <p:nvSpPr>
-          <p:cNvPr id="1134539449" name="PlaceHolder 6"/>
+          <p:cNvPr id="1082577428" name="PlaceHolder 6"/>
           <p:cNvSpPr>
             <a:spLocks noGrp="1"/>
           </p:cNvSpPr>
@@ -1018,7 +1018,7 @@
       </p:grpSpPr>
       <p:sp>
         <p:nvSpPr>
-          <p:cNvPr id="1967412134" name="PlaceHolder 1"/>
+          <p:cNvPr id="1650656520" name="PlaceHolder 1"/>
           <p:cNvSpPr>
             <a:spLocks noGrp="1"/>
           </p:cNvSpPr>
@@ -1059,7 +1059,7 @@
       </p:sp>
       <p:sp>
         <p:nvSpPr>
-          <p:cNvPr id="707620798" name="PlaceHolder 2"/>
+          <p:cNvPr id="1331434019" name="PlaceHolder 2"/>
           <p:cNvSpPr>
             <a:spLocks noGrp="1"/>
           </p:cNvSpPr>
@@ -1103,7 +1103,7 @@
       </p:sp>
       <p:sp>
         <p:nvSpPr>
-          <p:cNvPr id="1764009441" name="PlaceHolder 3"/>
+          <p:cNvPr id="1690184681" name="PlaceHolder 3"/>
           <p:cNvSpPr>
             <a:spLocks noGrp="1"/>
           </p:cNvSpPr>
@@ -1147,7 +1147,7 @@
       </p:sp>
       <p:sp>
         <p:nvSpPr>
-          <p:cNvPr id="1761094347" name="PlaceHolder 4"/>
+          <p:cNvPr id="1109485929" name="PlaceHolder 4"/>
           <p:cNvSpPr>
             <a:spLocks noGrp="1"/>
           </p:cNvSpPr>
@@ -1191,7 +1191,7 @@
       </p:sp>
       <p:sp>
         <p:nvSpPr>
-          <p:cNvPr id="2113219638" name="PlaceHolder 5"/>
+          <p:cNvPr id="1300691955" name="PlaceHolder 5"/>
           <p:cNvSpPr>
             <a:spLocks noGrp="1"/>
           </p:cNvSpPr>
@@ -1235,7 +1235,7 @@
       </p:sp>
       <p:sp>
         <p:nvSpPr>
-          <p:cNvPr id="448101814" name="PlaceHolder 6"/>
+          <p:cNvPr id="713771927" name="PlaceHolder 6"/>
           <p:cNvSpPr>
             <a:spLocks noGrp="1"/>
           </p:cNvSpPr>
@@ -1260,7 +1260,7 @@
       </p:sp>
       <p:sp>
         <p:nvSpPr>
-          <p:cNvPr id="1659729383" name="PlaceHolder 7"/>
+          <p:cNvPr id="1780103133" name="PlaceHolder 7"/>
           <p:cNvSpPr>
             <a:spLocks noGrp="1"/>
           </p:cNvSpPr>
@@ -1285,7 +1285,7 @@
       </p:sp>
       <p:sp>
         <p:nvSpPr>
-          <p:cNvPr id="1223278607" name="PlaceHolder 8"/>
+          <p:cNvPr id="183429173" name="PlaceHolder 8"/>
           <p:cNvSpPr>
             <a:spLocks noGrp="1"/>
           </p:cNvSpPr>
@@ -1331,7 +1331,7 @@
       </p:grpSpPr>
       <p:sp>
         <p:nvSpPr>
-          <p:cNvPr id="956762612" name="PlaceHolder 1"/>
+          <p:cNvPr id="1363680616" name="PlaceHolder 1"/>
           <p:cNvSpPr>
             <a:spLocks noGrp="1"/>
           </p:cNvSpPr>
@@ -1372,7 +1372,7 @@
       </p:sp>
       <p:sp>
         <p:nvSpPr>
-          <p:cNvPr id="305451021" name="PlaceHolder 2"/>
+          <p:cNvPr id="1298163190" name="PlaceHolder 2"/>
           <p:cNvSpPr>
             <a:spLocks noGrp="1"/>
           </p:cNvSpPr>
@@ -1416,7 +1416,7 @@
       </p:sp>
       <p:sp>
         <p:nvSpPr>
-          <p:cNvPr id="757010010" name="PlaceHolder 3"/>
+          <p:cNvPr id="342671139" name="PlaceHolder 3"/>
           <p:cNvSpPr>
             <a:spLocks noGrp="1"/>
           </p:cNvSpPr>
@@ -1460,7 +1460,7 @@
       </p:sp>
       <p:sp>
         <p:nvSpPr>
-          <p:cNvPr id="1472077763" name="PlaceHolder 4"/>
+          <p:cNvPr id="972841716" name="PlaceHolder 4"/>
           <p:cNvSpPr>
             <a:spLocks noGrp="1"/>
           </p:cNvSpPr>
@@ -1504,7 +1504,7 @@
       </p:sp>
       <p:sp>
         <p:nvSpPr>
-          <p:cNvPr id="1009547308" name="PlaceHolder 5"/>
+          <p:cNvPr id="1874236602" name="PlaceHolder 5"/>
           <p:cNvSpPr>
             <a:spLocks noGrp="1"/>
           </p:cNvSpPr>
@@ -1548,7 +1548,7 @@
       </p:sp>
       <p:sp>
         <p:nvSpPr>
-          <p:cNvPr id="2099890178" name="PlaceHolder 6"/>
+          <p:cNvPr id="184587114" name="PlaceHolder 6"/>
           <p:cNvSpPr>
             <a:spLocks noGrp="1"/>
           </p:cNvSpPr>
@@ -1592,7 +1592,7 @@
       </p:sp>
       <p:sp>
         <p:nvSpPr>
-          <p:cNvPr id="1719182510" name="PlaceHolder 7"/>
+          <p:cNvPr id="697625619" name="PlaceHolder 7"/>
           <p:cNvSpPr>
             <a:spLocks noGrp="1"/>
           </p:cNvSpPr>
@@ -1636,7 +1636,7 @@
       </p:sp>
       <p:sp>
         <p:nvSpPr>
-          <p:cNvPr id="1753242913" name="PlaceHolder 8"/>
+          <p:cNvPr id="706752610" name="PlaceHolder 8"/>
           <p:cNvSpPr>
             <a:spLocks noGrp="1"/>
           </p:cNvSpPr>
@@ -1661,7 +1661,7 @@
       </p:sp>
       <p:sp>
         <p:nvSpPr>
-          <p:cNvPr id="123640261" name="PlaceHolder 9"/>
+          <p:cNvPr id="764465904" name="PlaceHolder 9"/>
           <p:cNvSpPr>
             <a:spLocks noGrp="1"/>
           </p:cNvSpPr>
@@ -1686,7 +1686,7 @@
       </p:sp>
       <p:sp>
         <p:nvSpPr>
-          <p:cNvPr id="148257248" name="PlaceHolder 10"/>
+          <p:cNvPr id="1999288518" name="PlaceHolder 10"/>
           <p:cNvSpPr>
             <a:spLocks noGrp="1"/>
           </p:cNvSpPr>
@@ -1732,7 +1732,7 @@
       </p:grpSpPr>
       <p:sp>
         <p:nvSpPr>
-          <p:cNvPr id="29935925" name="PlaceHolder 1"/>
+          <p:cNvPr id="854624943" name="PlaceHolder 1"/>
           <p:cNvSpPr>
             <a:spLocks noGrp="1"/>
           </p:cNvSpPr>
@@ -1773,7 +1773,7 @@
       </p:sp>
       <p:sp>
         <p:nvSpPr>
-          <p:cNvPr id="1082293669" name="PlaceHolder 2"/>
+          <p:cNvPr id="334602302" name="PlaceHolder 2"/>
           <p:cNvSpPr>
             <a:spLocks noGrp="1"/>
           </p:cNvSpPr>
@@ -1814,7 +1814,7 @@
       </p:sp>
       <p:sp>
         <p:nvSpPr>
-          <p:cNvPr id="1475845759" name="PlaceHolder 3"/>
+          <p:cNvPr id="679563348" name="PlaceHolder 3"/>
           <p:cNvSpPr>
             <a:spLocks noGrp="1"/>
           </p:cNvSpPr>
@@ -1839,7 +1839,7 @@
       </p:sp>
       <p:sp>
         <p:nvSpPr>
-          <p:cNvPr id="1471184584" name="PlaceHolder 4"/>
+          <p:cNvPr id="1136910055" name="PlaceHolder 4"/>
           <p:cNvSpPr>
             <a:spLocks noGrp="1"/>
           </p:cNvSpPr>
@@ -1864,7 +1864,7 @@
       </p:sp>
       <p:sp>
         <p:nvSpPr>
-          <p:cNvPr id="1174202778" name="PlaceHolder 5"/>
+          <p:cNvPr id="805701962" name="PlaceHolder 5"/>
           <p:cNvSpPr>
             <a:spLocks noGrp="1"/>
           </p:cNvSpPr>
@@ -1910,7 +1910,7 @@
       </p:grpSpPr>
       <p:sp>
         <p:nvSpPr>
-          <p:cNvPr id="1166249348" name="PlaceHolder 1"/>
+          <p:cNvPr id="1462453374" name="PlaceHolder 1"/>
           <p:cNvSpPr>
             <a:spLocks noGrp="1"/>
           </p:cNvSpPr>
@@ -1951,7 +1951,7 @@
       </p:sp>
       <p:sp>
         <p:nvSpPr>
-          <p:cNvPr id="1424187342" name="PlaceHolder 2"/>
+          <p:cNvPr id="1429441972" name="PlaceHolder 2"/>
           <p:cNvSpPr>
             <a:spLocks noGrp="1"/>
           </p:cNvSpPr>
@@ -1995,7 +1995,7 @@
       </p:sp>
       <p:sp>
         <p:nvSpPr>
-          <p:cNvPr id="543995670" name="PlaceHolder 3"/>
+          <p:cNvPr id="919434884" name="PlaceHolder 3"/>
           <p:cNvSpPr>
             <a:spLocks noGrp="1"/>
           </p:cNvSpPr>
@@ -2020,7 +2020,7 @@
       </p:sp>
       <p:sp>
         <p:nvSpPr>
-          <p:cNvPr id="211485857" name="PlaceHolder 4"/>
+          <p:cNvPr id="314550139" name="PlaceHolder 4"/>
           <p:cNvSpPr>
             <a:spLocks noGrp="1"/>
           </p:cNvSpPr>
@@ -2045,7 +2045,7 @@
       </p:sp>
       <p:sp>
         <p:nvSpPr>
-          <p:cNvPr id="1042771902" name="PlaceHolder 5"/>
+          <p:cNvPr id="1356421624" name="PlaceHolder 5"/>
           <p:cNvSpPr>
             <a:spLocks noGrp="1"/>
           </p:cNvSpPr>
@@ -2091,7 +2091,7 @@
       </p:grpSpPr>
       <p:sp>
         <p:nvSpPr>
-          <p:cNvPr id="1391793084" name="PlaceHolder 1"/>
+          <p:cNvPr id="1122745076" name="PlaceHolder 1"/>
           <p:cNvSpPr>
             <a:spLocks noGrp="1"/>
           </p:cNvSpPr>
@@ -2132,7 +2132,7 @@
       </p:sp>
       <p:sp>
         <p:nvSpPr>
-          <p:cNvPr id="617828017" name="PlaceHolder 2"/>
+          <p:cNvPr id="530327046" name="PlaceHolder 2"/>
           <p:cNvSpPr>
             <a:spLocks noGrp="1"/>
           </p:cNvSpPr>
@@ -2176,7 +2176,7 @@
       </p:sp>
       <p:sp>
         <p:nvSpPr>
-          <p:cNvPr id="134295560" name="PlaceHolder 3"/>
+          <p:cNvPr id="1604053893" name="PlaceHolder 3"/>
           <p:cNvSpPr>
             <a:spLocks noGrp="1"/>
           </p:cNvSpPr>
@@ -2220,7 +2220,7 @@
       </p:sp>
       <p:sp>
         <p:nvSpPr>
-          <p:cNvPr id="1595195839" name="PlaceHolder 4"/>
+          <p:cNvPr id="1574873792" name="PlaceHolder 4"/>
           <p:cNvSpPr>
             <a:spLocks noGrp="1"/>
           </p:cNvSpPr>
@@ -2245,7 +2245,7 @@
       </p:sp>
       <p:sp>
         <p:nvSpPr>
-          <p:cNvPr id="1588505712" name="PlaceHolder 5"/>
+          <p:cNvPr id="270962127" name="PlaceHolder 5"/>
           <p:cNvSpPr>
             <a:spLocks noGrp="1"/>
           </p:cNvSpPr>
@@ -2270,7 +2270,7 @@
       </p:sp>
       <p:sp>
         <p:nvSpPr>
-          <p:cNvPr id="1157103434" name="PlaceHolder 6"/>
+          <p:cNvPr id="996907091" name="PlaceHolder 6"/>
           <p:cNvSpPr>
             <a:spLocks noGrp="1"/>
           </p:cNvSpPr>
@@ -2316,7 +2316,7 @@
       </p:grpSpPr>
       <p:sp>
         <p:nvSpPr>
-          <p:cNvPr id="1906085353" name="PlaceHolder 1"/>
+          <p:cNvPr id="793241313" name="PlaceHolder 1"/>
           <p:cNvSpPr>
             <a:spLocks noGrp="1"/>
           </p:cNvSpPr>
@@ -2357,7 +2357,7 @@
       </p:sp>
       <p:sp>
         <p:nvSpPr>
-          <p:cNvPr id="1032870724" name="PlaceHolder 2"/>
+          <p:cNvPr id="1140270091" name="PlaceHolder 2"/>
           <p:cNvSpPr>
             <a:spLocks noGrp="1"/>
           </p:cNvSpPr>
@@ -2382,7 +2382,7 @@
       </p:sp>
       <p:sp>
         <p:nvSpPr>
-          <p:cNvPr id="1592063584" name="PlaceHolder 3"/>
+          <p:cNvPr id="1871912310" name="PlaceHolder 3"/>
           <p:cNvSpPr>
             <a:spLocks noGrp="1"/>
           </p:cNvSpPr>
@@ -2407,7 +2407,7 @@
       </p:sp>
       <p:sp>
         <p:nvSpPr>
-          <p:cNvPr id="1765109003" name="PlaceHolder 4"/>
+          <p:cNvPr id="501156095" name="PlaceHolder 4"/>
           <p:cNvSpPr>
             <a:spLocks noGrp="1"/>
           </p:cNvSpPr>
@@ -2453,7 +2453,7 @@
       </p:grpSpPr>
       <p:sp>
         <p:nvSpPr>
-          <p:cNvPr id="1838658786" name="PlaceHolder 1"/>
+          <p:cNvPr id="198890899" name="PlaceHolder 1"/>
           <p:cNvSpPr>
             <a:spLocks noGrp="1"/>
           </p:cNvSpPr>
@@ -2493,7 +2493,7 @@
       </p:sp>
       <p:sp>
         <p:nvSpPr>
-          <p:cNvPr id="1904953911" name="PlaceHolder 2"/>
+          <p:cNvPr id="1659024618" name="PlaceHolder 2"/>
           <p:cNvSpPr>
             <a:spLocks noGrp="1"/>
           </p:cNvSpPr>
@@ -2518,7 +2518,7 @@
       </p:sp>
       <p:sp>
         <p:nvSpPr>
-          <p:cNvPr id="815872622" name="PlaceHolder 3"/>
+          <p:cNvPr id="469647720" name="PlaceHolder 3"/>
           <p:cNvSpPr>
             <a:spLocks noGrp="1"/>
           </p:cNvSpPr>
@@ -2543,7 +2543,7 @@
       </p:sp>
       <p:sp>
         <p:nvSpPr>
-          <p:cNvPr id="961984754" name="PlaceHolder 4"/>
+          <p:cNvPr id="1587407411" name="PlaceHolder 4"/>
           <p:cNvSpPr>
             <a:spLocks noGrp="1"/>
           </p:cNvSpPr>
@@ -2589,7 +2589,7 @@
       </p:grpSpPr>
       <p:sp>
         <p:nvSpPr>
-          <p:cNvPr id="355040209" name="PlaceHolder 1"/>
+          <p:cNvPr id="330735335" name="PlaceHolder 1"/>
           <p:cNvSpPr>
             <a:spLocks noGrp="1"/>
           </p:cNvSpPr>
@@ -2630,7 +2630,7 @@
       </p:sp>
       <p:sp>
         <p:nvSpPr>
-          <p:cNvPr id="475841933" name="PlaceHolder 2"/>
+          <p:cNvPr id="1158791433" name="PlaceHolder 2"/>
           <p:cNvSpPr>
             <a:spLocks noGrp="1"/>
           </p:cNvSpPr>
@@ -2674,7 +2674,7 @@
       </p:sp>
       <p:sp>
         <p:nvSpPr>
-          <p:cNvPr id="1707070051" name="PlaceHolder 3"/>
+          <p:cNvPr id="89429102" name="PlaceHolder 3"/>
           <p:cNvSpPr>
             <a:spLocks noGrp="1"/>
           </p:cNvSpPr>
@@ -2718,7 +2718,7 @@
       </p:sp>
       <p:sp>
         <p:nvSpPr>
-          <p:cNvPr id="914974578" name="PlaceHolder 4"/>
+          <p:cNvPr id="263647595" name="PlaceHolder 4"/>
           <p:cNvSpPr>
             <a:spLocks noGrp="1"/>
           </p:cNvSpPr>
@@ -2762,7 +2762,7 @@
       </p:sp>
       <p:sp>
         <p:nvSpPr>
-          <p:cNvPr id="321158656" name="PlaceHolder 5"/>
+          <p:cNvPr id="855886094" name="PlaceHolder 5"/>
           <p:cNvSpPr>
             <a:spLocks noGrp="1"/>
           </p:cNvSpPr>
@@ -2787,7 +2787,7 @@
       </p:sp>
       <p:sp>
         <p:nvSpPr>
-          <p:cNvPr id="505416596" name="PlaceHolder 6"/>
+          <p:cNvPr id="267191694" name="PlaceHolder 6"/>
           <p:cNvSpPr>
             <a:spLocks noGrp="1"/>
           </p:cNvSpPr>
@@ -2812,7 +2812,7 @@
       </p:sp>
       <p:sp>
         <p:nvSpPr>
-          <p:cNvPr id="1163403882" name="PlaceHolder 7"/>
+          <p:cNvPr id="1114146103" name="PlaceHolder 7"/>
           <p:cNvSpPr>
             <a:spLocks noGrp="1"/>
           </p:cNvSpPr>
@@ -2858,7 +2858,7 @@
       </p:grpSpPr>
       <p:sp>
         <p:nvSpPr>
-          <p:cNvPr id="773248138" name="PlaceHolder 1"/>
+          <p:cNvPr id="1269735701" name="PlaceHolder 1"/>
           <p:cNvSpPr>
             <a:spLocks noGrp="1"/>
           </p:cNvSpPr>
@@ -2899,7 +2899,7 @@
       </p:sp>
       <p:sp>
         <p:nvSpPr>
-          <p:cNvPr id="1907962360" name="PlaceHolder 2"/>
+          <p:cNvPr id="371619054" name="PlaceHolder 2"/>
           <p:cNvSpPr>
             <a:spLocks noGrp="1"/>
           </p:cNvSpPr>
@@ -2943,7 +2943,7 @@
       </p:sp>
       <p:sp>
         <p:nvSpPr>
-          <p:cNvPr id="32688519" name="PlaceHolder 3"/>
+          <p:cNvPr id="45429675" name="PlaceHolder 3"/>
           <p:cNvSpPr>
             <a:spLocks noGrp="1"/>
           </p:cNvSpPr>
@@ -2987,7 +2987,7 @@
       </p:sp>
       <p:sp>
         <p:nvSpPr>
-          <p:cNvPr id="104786120" name="PlaceHolder 4"/>
+          <p:cNvPr id="1505585351" name="PlaceHolder 4"/>
           <p:cNvSpPr>
             <a:spLocks noGrp="1"/>
           </p:cNvSpPr>
@@ -3031,7 +3031,7 @@
       </p:sp>
       <p:sp>
         <p:nvSpPr>
-          <p:cNvPr id="95541643" name="PlaceHolder 5"/>
+          <p:cNvPr id="935512903" name="PlaceHolder 5"/>
           <p:cNvSpPr>
             <a:spLocks noGrp="1"/>
           </p:cNvSpPr>
@@ -3056,7 +3056,7 @@
       </p:sp>
       <p:sp>
         <p:nvSpPr>
-          <p:cNvPr id="556845942" name="PlaceHolder 6"/>
+          <p:cNvPr id="1822680219" name="PlaceHolder 6"/>
           <p:cNvSpPr>
             <a:spLocks noGrp="1"/>
           </p:cNvSpPr>
@@ -3081,7 +3081,7 @@
       </p:sp>
       <p:sp>
         <p:nvSpPr>
-          <p:cNvPr id="1669402992" name="PlaceHolder 7"/>
+          <p:cNvPr id="504091786" name="PlaceHolder 7"/>
           <p:cNvSpPr>
             <a:spLocks noGrp="1"/>
           </p:cNvSpPr>
@@ -3127,7 +3127,7 @@
       </p:grpSpPr>
       <p:sp>
         <p:nvSpPr>
-          <p:cNvPr id="1762733427" name="PlaceHolder 1"/>
+          <p:cNvPr id="2072938643" name="PlaceHolder 1"/>
           <p:cNvSpPr>
             <a:spLocks noGrp="1"/>
           </p:cNvSpPr>
@@ -3168,7 +3168,7 @@
       </p:sp>
       <p:sp>
         <p:nvSpPr>
-          <p:cNvPr id="1905403272" name="PlaceHolder 2"/>
+          <p:cNvPr id="1019871278" name="PlaceHolder 2"/>
           <p:cNvSpPr>
             <a:spLocks noGrp="1"/>
           </p:cNvSpPr>
@@ -3212,7 +3212,7 @@
       </p:sp>
       <p:sp>
         <p:nvSpPr>
-          <p:cNvPr id="2035969262" name="PlaceHolder 3"/>
+          <p:cNvPr id="239760341" name="PlaceHolder 3"/>
           <p:cNvSpPr>
             <a:spLocks noGrp="1"/>
           </p:cNvSpPr>
@@ -3256,7 +3256,7 @@
       </p:sp>
       <p:sp>
         <p:nvSpPr>
-          <p:cNvPr id="378741444" name="PlaceHolder 4"/>
+          <p:cNvPr id="1638101780" name="PlaceHolder 4"/>
           <p:cNvSpPr>
             <a:spLocks noGrp="1"/>
           </p:cNvSpPr>
@@ -3300,7 +3300,7 @@
       </p:sp>
       <p:sp>
         <p:nvSpPr>
-          <p:cNvPr id="1400814005" name="PlaceHolder 5"/>
+          <p:cNvPr id="1854930524" name="PlaceHolder 5"/>
           <p:cNvSpPr>
             <a:spLocks noGrp="1"/>
           </p:cNvSpPr>
@@ -3325,7 +3325,7 @@
       </p:sp>
       <p:sp>
         <p:nvSpPr>
-          <p:cNvPr id="317644392" name="PlaceHolder 6"/>
+          <p:cNvPr id="77913567" name="PlaceHolder 6"/>
           <p:cNvSpPr>
             <a:spLocks noGrp="1"/>
           </p:cNvSpPr>
@@ -3350,7 +3350,7 @@
       </p:sp>
       <p:sp>
         <p:nvSpPr>
-          <p:cNvPr id="387684185" name="PlaceHolder 7"/>
+          <p:cNvPr id="786962858" name="PlaceHolder 7"/>
           <p:cNvSpPr>
             <a:spLocks noGrp="1"/>
           </p:cNvSpPr>
@@ -3403,7 +3403,7 @@
       </p:grpSpPr>
       <p:sp>
         <p:nvSpPr>
-          <p:cNvPr id="778682035" name="PlaceHolder 1"/>
+          <p:cNvPr id="982169013" name="PlaceHolder 1"/>
           <p:cNvSpPr>
             <a:spLocks noGrp="1"/>
           </p:cNvSpPr>
@@ -3464,7 +3464,7 @@
       </p:sp>
       <p:sp>
         <p:nvSpPr>
-          <p:cNvPr id="743343460" name="PlaceHolder 2"/>
+          <p:cNvPr id="1034438032" name="PlaceHolder 2"/>
           <p:cNvSpPr>
             <a:spLocks noGrp="1"/>
           </p:cNvSpPr>
@@ -3525,7 +3525,7 @@
       </p:sp>
       <p:sp>
         <p:nvSpPr>
-          <p:cNvPr id="1692066674" name="PlaceHolder 3"/>
+          <p:cNvPr id="737131647" name="PlaceHolder 3"/>
           <p:cNvSpPr>
             <a:spLocks noGrp="1"/>
           </p:cNvSpPr>
@@ -3600,7 +3600,7 @@
       </p:sp>
       <p:sp>
         <p:nvSpPr>
-          <p:cNvPr id="354374656" name="PlaceHolder 4"/>
+          <p:cNvPr id="210132230" name="PlaceHolder 4"/>
           <p:cNvSpPr>
             <a:spLocks noGrp="1"/>
           </p:cNvSpPr>
@@ -3650,7 +3650,7 @@
       </p:sp>
       <p:sp>
         <p:nvSpPr>
-          <p:cNvPr id="456422250" name="PlaceHolder 5"/>
+          <p:cNvPr id="2123436500" name="PlaceHolder 5"/>
           <p:cNvSpPr>
             <a:spLocks noGrp="1"/>
           </p:cNvSpPr>
@@ -3926,7 +3926,7 @@
       </p:grpSpPr>
       <p:sp>
         <p:nvSpPr>
-          <p:cNvPr id="1287229215" name="Google Shape;84;p13"/>
+          <p:cNvPr id="774306819" name="Google Shape;84;p13"/>
           <p:cNvSpPr/>
           <p:nvPr/>
         </p:nvSpPr>
@@ -3979,14 +3979,14 @@
       </p:sp>
       <p:sp>
         <p:nvSpPr>
-          <p:cNvPr id="1535372550" name="Google Shape;85;p13"/>
+          <p:cNvPr id="1527426980" name="Google Shape;85;p13"/>
           <p:cNvSpPr/>
           <p:nvPr/>
         </p:nvSpPr>
         <p:spPr bwMode="auto">
           <a:xfrm>
-            <a:off x="609480" y="2187000"/>
-            <a:ext cx="9120959" cy="1408535"/>
+            <a:off x="990479" y="2187000"/>
+            <a:ext cx="9130679" cy="1408535"/>
           </a:xfrm>
           <a:prstGeom prst="rect">
             <a:avLst/>
@@ -4024,7 +4024,7 @@
                 <a:latin typeface="Space Grotesk"/>
                 <a:ea typeface="Space Grotesk"/>
               </a:rPr>
-              <a:t>Tugas EAS: Team Project (collaborative)</a:t>
+              <a:t>Tugas ETS: Team Project (kolaboratif)</a:t>
             </a:r>
             <a:endParaRPr lang="en-US" sz="4200" b="0" strike="noStrike" spc="-1">
               <a:solidFill>
@@ -4037,7 +4037,7 @@
       </p:sp>
       <p:sp>
         <p:nvSpPr>
-          <p:cNvPr id="1022705360" name="Google Shape;87;p13"/>
+          <p:cNvPr id="516384508" name="Google Shape;87;p13"/>
           <p:cNvSpPr/>
           <p:nvPr/>
         </p:nvSpPr>
@@ -4135,14 +4135,14 @@
       </p:grpSpPr>
       <p:sp>
         <p:nvSpPr>
-          <p:cNvPr id="1051127128" name="Google Shape;102;p14"/>
+          <p:cNvPr id="1732518846" name="Google Shape;102;p14"/>
           <p:cNvSpPr/>
           <p:nvPr/>
         </p:nvSpPr>
         <p:spPr bwMode="auto">
           <a:xfrm>
             <a:off x="609480" y="771480"/>
-            <a:ext cx="11604959" cy="731879"/>
+            <a:ext cx="11605319" cy="731879"/>
           </a:xfrm>
           <a:prstGeom prst="rect">
             <a:avLst/>
@@ -4181,7 +4181,7 @@
                 <a:ea typeface="Liberation Sans"/>
                 <a:cs typeface="Liberation Sans"/>
               </a:rPr>
-              <a:t>Project kelompok sebagai UTS</a:t>
+              <a:t>Project kelompok sebagai ETS</a:t>
             </a:r>
             <a:endParaRPr sz="4800" b="0" strike="noStrike" spc="-1">
               <a:solidFill>
@@ -4202,7 +4202,7 @@
         <p:spPr bwMode="auto">
           <a:xfrm rot="0" flipH="0" flipV="0">
             <a:off x="895230" y="1804901"/>
-            <a:ext cx="11298750" cy="4480919"/>
+            <a:ext cx="11301990" cy="4480919"/>
           </a:xfrm>
           <a:prstGeom prst="rect">
             <a:avLst/>
@@ -4225,7 +4225,7 @@
                 <a:ea typeface="Liberation Sans"/>
                 <a:cs typeface="Liberation Sans"/>
               </a:rPr>
-              <a:t>Buat pipeline pemrosesan data (akuisisi, pengolahan, presentasi) dari irisan/gabungan topik skripsi masing-masing angota</a:t>
+              <a:t>Buat pipeline pemrosesan data (akuisisi, pengolahan, presentasi) dari irisan/gabungan/pilihan topik skripsi masing-masing angota</a:t>
             </a:r>
             <a:endParaRPr sz="2400">
               <a:latin typeface="Liberation Sans"/>
@@ -4281,7 +4281,7 @@
                 <a:ea typeface="Liberation Sans"/>
                 <a:cs typeface="Liberation Sans"/>
               </a:rPr>
-              <a:t>Presentasi menjelang jadwal UTS, alokasi waktu hingga 15+5 menit</a:t>
+              <a:t>Presentasi menjelang jadwal ETS, alokasi waktu hingga 15+5 menit</a:t>
             </a:r>
             <a:endParaRPr sz="2400" b="0" i="0">
               <a:latin typeface="Liberation Sans"/>
@@ -4585,7 +4585,7 @@
         <p:spPr bwMode="auto">
           <a:xfrm rot="0" flipH="0" flipV="0">
             <a:off x="895230" y="1804900"/>
-            <a:ext cx="10965089" cy="3749399"/>
+            <a:ext cx="10967969" cy="3749399"/>
           </a:xfrm>
           <a:prstGeom prst="rect">
             <a:avLst/>
@@ -4616,7 +4616,7 @@
                 <a:ea typeface="Liberation Sans"/>
                 <a:cs typeface="Liberation Sans"/>
               </a:rPr>
-              <a:t>(mudah dipahami, latar belakang jelas dan bermanfaat/berdampak): 30%</a:t>
+              <a:t>(mudah dipahami, latar belakang jelas dan kebermanfaatan/keberdampakan): 30%</a:t>
             </a:r>
             <a:endParaRPr sz="2400">
               <a:latin typeface="Liberation Sans"/>

</xml_diff>